<commit_message>
feat(dc): Add drop-copy observability: pm-dc-spy and ALF DC relay
New pm-dc-spy CLI: read-only ZMQ SUB client for the engine's drop-copy
  feed (:5557), mirroring pm-calf-spy's --format/--count/--raw conventions.
  Supports --gateway filtering and --replay-of for observing
  DropCopyPublisher.replay() traffic.

- New DC|STATE=ON|OFF command on pm-alf-gwy and pm-alf-console: relays
  drop_copy.event.{gateway_id} down a participant's own ALF session as
  async DC_FILL lines, scoped to that gateway's own fills. Closer to how
  real exchanges deliver drop copy (per-participant session relay) than a
  raw unauthenticated ZMQ subscription. pm-alf-console also gains a
  --drop-copy startup flag (default off).

- External clients still connect directly to :5557 (unauthenticated by
  design, consistent with the rest of EduMatcher's ZMQ bus).
</commit_message>
<xml_diff>
--- a/docs/presentations/introduction-to-edumatcher.pptx
+++ b/docs/presentations/introduction-to-edumatcher.pptx
@@ -10497,8 +10497,8 @@
         </p:nvSpPr>
         <p:spPr>
           <a:xfrm>
-            <a:off x="4470000" y="3810000"/>
-            <a:ext cx="4107072" cy="760000"/>
+            <a:off x="4470000" y="3809999"/>
+            <a:ext cx="4107072" cy="1048247"/>
           </a:xfrm>
           <a:prstGeom prst="rect">
             <a:avLst/>
@@ -10517,7 +10517,7 @@
               <a:buNone/>
             </a:pPr>
             <a:r>
-              <a:rPr lang="en-US" sz="1050" kern="0">
+              <a:rPr lang="en-US" sz="1050" kern="0" dirty="0">
                 <a:solidFill>
                   <a:srgbClr val="ECECEC"/>
                 </a:solidFill>
@@ -10527,7 +10527,28 @@
               </a:rPr>
               <a:t>Gateway-ID allowlisting is enforced. Supports the full order set including COMBO and OCO, all Time-in-Force codes (DAY / GTC / GTD / IOC / FOK + ATO / ATC) and self-match prevention.</a:t>
             </a:r>
-            <a:endParaRPr lang="en-US"/>
+            <a:br>
+              <a:rPr lang="en-US" sz="1050" kern="0" dirty="0">
+                <a:solidFill>
+                  <a:srgbClr val="ECECEC"/>
+                </a:solidFill>
+                <a:latin typeface="Calibri" pitchFamily="34" charset="0"/>
+                <a:ea typeface="Calibri" pitchFamily="34" charset="-122"/>
+                <a:cs typeface="Calibri" pitchFamily="34" charset="-120"/>
+              </a:rPr>
+            </a:br>
+            <a:r>
+              <a:rPr lang="en-US" sz="1050" kern="0" dirty="0">
+                <a:solidFill>
+                  <a:srgbClr val="ECECEC"/>
+                </a:solidFill>
+                <a:latin typeface="Calibri" pitchFamily="34" charset="0"/>
+                <a:ea typeface="Calibri" pitchFamily="34" charset="-122"/>
+                <a:cs typeface="Calibri" pitchFamily="34" charset="-120"/>
+              </a:rPr>
+              <a:t>DC ON/OFF control whether a Drop-Copy (DC) is sent back after each fill</a:t>
+            </a:r>
+            <a:endParaRPr lang="en-US" dirty="0"/>
           </a:p>
         </p:txBody>
       </p:sp>
@@ -20350,7 +20371,7 @@
               <a:buNone/>
             </a:pPr>
             <a:r>
-              <a:rPr lang="en-US" sz="1050" b="1" kern="0">
+              <a:rPr lang="en-US" sz="1050" b="1" kern="0" dirty="0">
                 <a:solidFill>
                   <a:srgbClr val="F2860D"/>
                 </a:solidFill>
@@ -20361,7 +20382,7 @@
               <a:t>PULL :5555   </a:t>
             </a:r>
             <a:r>
-              <a:rPr lang="en-US" sz="1000" kern="0">
+              <a:rPr lang="en-US" sz="1000" kern="0" dirty="0">
                 <a:solidFill>
                   <a:srgbClr val="B4B4BE"/>
                 </a:solidFill>
@@ -20371,7 +20392,7 @@
               </a:rPr>
               <a:t>orders in</a:t>
             </a:r>
-            <a:endParaRPr lang="en-US"/>
+            <a:endParaRPr lang="en-US" dirty="0"/>
           </a:p>
           <a:p>
             <a:pPr marL="0" indent="0" algn="l">
@@ -20384,7 +20405,7 @@
               <a:buNone/>
             </a:pPr>
             <a:r>
-              <a:rPr lang="en-US" sz="1050" b="1" kern="0">
+              <a:rPr lang="en-US" sz="1050" b="1" kern="0" dirty="0">
                 <a:solidFill>
                   <a:srgbClr val="5B9BF5"/>
                 </a:solidFill>
@@ -20395,7 +20416,7 @@
               <a:t>PUB  :5556   </a:t>
             </a:r>
             <a:r>
-              <a:rPr lang="en-US" sz="1000" kern="0">
+              <a:rPr lang="en-US" sz="1000" kern="0" dirty="0">
                 <a:solidFill>
                   <a:srgbClr val="B4B4BE"/>
                 </a:solidFill>
@@ -20405,7 +20426,7 @@
               </a:rPr>
               <a:t>events out</a:t>
             </a:r>
-            <a:endParaRPr lang="en-US"/>
+            <a:endParaRPr lang="en-US" dirty="0"/>
           </a:p>
           <a:p>
             <a:pPr marL="0" indent="0" algn="l">
@@ -20418,7 +20439,7 @@
               <a:buNone/>
             </a:pPr>
             <a:r>
-              <a:rPr lang="en-US" sz="1050" b="1" kern="0">
+              <a:rPr lang="en-US" sz="1050" b="1" kern="0" dirty="0">
                 <a:solidFill>
                   <a:srgbClr val="5FC98E"/>
                 </a:solidFill>
@@ -20429,7 +20450,7 @@
               <a:t>PUB  :5557   </a:t>
             </a:r>
             <a:r>
-              <a:rPr lang="en-US" sz="1000" kern="0">
+              <a:rPr lang="en-US" sz="1000" kern="0" dirty="0">
                 <a:solidFill>
                   <a:srgbClr val="B4B4BE"/>
                 </a:solidFill>
@@ -20439,7 +20460,7 @@
               </a:rPr>
               <a:t>drop copy</a:t>
             </a:r>
-            <a:endParaRPr lang="en-US"/>
+            <a:endParaRPr lang="en-US" dirty="0"/>
           </a:p>
           <a:p>
             <a:pPr marL="0" indent="0" algn="l">
@@ -20452,7 +20473,7 @@
               <a:buNone/>
             </a:pPr>
             <a:r>
-              <a:rPr lang="en-US" sz="1050" b="1" kern="0">
+              <a:rPr lang="en-US" sz="1050" b="1" kern="0" dirty="0">
                 <a:solidFill>
                   <a:srgbClr val="B98CE0"/>
                 </a:solidFill>
@@ -20463,7 +20484,7 @@
               <a:t>PUB  :5558   </a:t>
             </a:r>
             <a:r>
-              <a:rPr lang="en-US" sz="1000" kern="0">
+              <a:rPr lang="en-US" sz="1000" kern="0" dirty="0">
                 <a:solidFill>
                   <a:srgbClr val="B4B4BE"/>
                 </a:solidFill>
@@ -20473,7 +20494,7 @@
               </a:rPr>
               <a:t>index publish</a:t>
             </a:r>
-            <a:endParaRPr lang="en-US"/>
+            <a:endParaRPr lang="en-US" dirty="0"/>
           </a:p>
           <a:p>
             <a:pPr marL="0" indent="0" algn="l">
@@ -20486,7 +20507,7 @@
               <a:buNone/>
             </a:pPr>
             <a:r>
-              <a:rPr lang="en-US" sz="1050" b="1" kern="0">
+              <a:rPr lang="en-US" sz="1050" b="1" kern="0" dirty="0">
                 <a:solidFill>
                   <a:srgbClr val="B98CE0"/>
                 </a:solidFill>
@@ -20497,7 +20518,7 @@
               <a:t>PULL :5559   </a:t>
             </a:r>
             <a:r>
-              <a:rPr lang="en-US" sz="1000" kern="0">
+              <a:rPr lang="en-US" sz="1000" kern="0" dirty="0">
                 <a:solidFill>
                   <a:srgbClr val="B4B4BE"/>
                 </a:solidFill>
@@ -20507,7 +20528,7 @@
               </a:rPr>
               <a:t>index admin</a:t>
             </a:r>
-            <a:endParaRPr lang="en-US"/>
+            <a:endParaRPr lang="en-US" dirty="0"/>
           </a:p>
         </p:txBody>
       </p:sp>
@@ -20890,7 +20911,7 @@
               <a:buNone/>
             </a:pPr>
             <a:r>
-              <a:rPr lang="en-US" sz="1000" kern="0">
+              <a:rPr lang="en-US" sz="1100" kern="0" dirty="0">
                 <a:solidFill>
                   <a:srgbClr val="ECECEC"/>
                 </a:solidFill>
@@ -20900,7 +20921,7 @@
               </a:rPr>
               <a:t>pm-engine is the single writer on :5555/:5556/:5557; pm-index adds :5558/:5559. Each gateway translates one external protocol onto that internal bus.</a:t>
             </a:r>
-            <a:endParaRPr lang="en-US"/>
+            <a:endParaRPr lang="en-US" sz="2400" dirty="0"/>
           </a:p>
         </p:txBody>
       </p:sp>
@@ -22054,7 +22075,7 @@
         </p:nvSpPr>
         <p:spPr>
           <a:xfrm>
-            <a:off x="566928" y="1330000"/>
+            <a:off x="566928" y="1226634"/>
             <a:ext cx="8010144" cy="300000"/>
           </a:xfrm>
           <a:prstGeom prst="rect">
@@ -22074,7 +22095,7 @@
               <a:buNone/>
             </a:pPr>
             <a:r>
-              <a:rPr lang="en-US" sz="1250" kern="0">
+              <a:rPr lang="en-US" sz="1250" kern="0" dirty="0">
                 <a:solidFill>
                   <a:srgbClr val="B4B4BE"/>
                 </a:solidFill>
@@ -22082,9 +22103,31 @@
                 <a:ea typeface="Calibri" pitchFamily="34" charset="-122"/>
                 <a:cs typeface="Calibri" pitchFamily="34" charset="-120"/>
               </a:rPr>
-              <a:t>Three independent consumers ride the same PUB :5556 event stream — RALF exposes them as CLEARING / DROP_COPY / AUDIT roles — giving the exchange a replayable system of record.</a:t>
-            </a:r>
-            <a:endParaRPr lang="en-US"/>
+              <a:t>Three independent consumers ride the same PUB :5556 event stream — RALF exposes them as CLEARING / DROP_COPY / AUDIT roles — giving the exchange a </a:t>
+            </a:r>
+            <a:r>
+              <a:rPr lang="en-US" sz="1250" kern="0" dirty="0" err="1">
+                <a:solidFill>
+                  <a:srgbClr val="B4B4BE"/>
+                </a:solidFill>
+                <a:latin typeface="Calibri" pitchFamily="34" charset="0"/>
+                <a:ea typeface="Calibri" pitchFamily="34" charset="-122"/>
+                <a:cs typeface="Calibri" pitchFamily="34" charset="-120"/>
+              </a:rPr>
+              <a:t>replayable</a:t>
+            </a:r>
+            <a:r>
+              <a:rPr lang="en-US" sz="1250" kern="0" dirty="0">
+                <a:solidFill>
+                  <a:srgbClr val="B4B4BE"/>
+                </a:solidFill>
+                <a:latin typeface="Calibri" pitchFamily="34" charset="0"/>
+                <a:ea typeface="Calibri" pitchFamily="34" charset="-122"/>
+                <a:cs typeface="Calibri" pitchFamily="34" charset="-120"/>
+              </a:rPr>
+              <a:t> system of record.</a:t>
+            </a:r>
+            <a:endParaRPr lang="en-US" dirty="0"/>
           </a:p>
         </p:txBody>
       </p:sp>
@@ -22193,7 +22236,7 @@
               <a:buNone/>
             </a:pPr>
             <a:r>
-              <a:rPr lang="en-US" sz="1000" b="1" kern="0" spc="100">
+              <a:rPr lang="en-US" sz="1400" b="1" kern="0" spc="100" dirty="0">
                 <a:solidFill>
                   <a:srgbClr val="5FC98E"/>
                 </a:solidFill>
@@ -22203,7 +22246,7 @@
               </a:rPr>
               <a:t>DROP COPY</a:t>
             </a:r>
-            <a:endParaRPr lang="en-US"/>
+            <a:endParaRPr lang="en-US" sz="3200" dirty="0"/>
           </a:p>
         </p:txBody>
       </p:sp>
@@ -22238,7 +22281,7 @@
               <a:buNone/>
             </a:pPr>
             <a:r>
-              <a:rPr lang="en-US" sz="1000" b="1" kern="0">
+              <a:rPr lang="en-US" sz="1200" b="1" kern="0" dirty="0">
                 <a:solidFill>
                   <a:srgbClr val="5FC98E"/>
                 </a:solidFill>
@@ -22248,7 +22291,7 @@
               </a:rPr>
               <a:t>Engine PUB :5557</a:t>
             </a:r>
-            <a:endParaRPr lang="en-US"/>
+            <a:endParaRPr lang="en-US" sz="2800" dirty="0"/>
           </a:p>
           <a:p>
             <a:pPr marL="0" indent="0" algn="l">
@@ -22261,7 +22304,7 @@
               <a:buNone/>
             </a:pPr>
             <a:r>
-              <a:rPr lang="en-US" sz="1000" kern="0">
+              <a:rPr lang="en-US" sz="1100" kern="0" dirty="0">
                 <a:solidFill>
                   <a:srgbClr val="ECECEC"/>
                 </a:solidFill>
@@ -22271,7 +22314,7 @@
               </a:rPr>
               <a:t>Per-participant fill stream</a:t>
             </a:r>
-            <a:endParaRPr lang="en-US"/>
+            <a:endParaRPr lang="en-US" sz="2400" dirty="0"/>
           </a:p>
           <a:p>
             <a:pPr marL="0" indent="0" algn="l">
@@ -22284,7 +22327,7 @@
               <a:buNone/>
             </a:pPr>
             <a:r>
-              <a:rPr lang="en-US" sz="1000" kern="0">
+              <a:rPr lang="en-US" sz="1050" kern="0" dirty="0">
                 <a:solidFill>
                   <a:srgbClr val="B4B4BE"/>
                 </a:solidFill>
@@ -22294,7 +22337,7 @@
               </a:rPr>
               <a:t>Sequence numbers + gap replay</a:t>
             </a:r>
-            <a:endParaRPr lang="en-US"/>
+            <a:endParaRPr lang="en-US" sz="2000" dirty="0"/>
           </a:p>
           <a:p>
             <a:pPr marL="0" indent="0" algn="l">
@@ -22307,7 +22350,7 @@
               <a:buNone/>
             </a:pPr>
             <a:r>
-              <a:rPr lang="en-US" sz="1000" kern="0">
+              <a:rPr lang="en-US" sz="1050" kern="0" dirty="0">
                 <a:solidFill>
                   <a:srgbClr val="ECECEC"/>
                 </a:solidFill>
@@ -22317,7 +22360,7 @@
               </a:rPr>
               <a:t>so a client can detect and</a:t>
             </a:r>
-            <a:endParaRPr lang="en-US"/>
+            <a:endParaRPr lang="en-US" sz="2000" dirty="0"/>
           </a:p>
           <a:p>
             <a:pPr marL="0" indent="0" algn="l">
@@ -22330,7 +22373,7 @@
               <a:buNone/>
             </a:pPr>
             <a:r>
-              <a:rPr lang="en-US" sz="1000" kern="0">
+              <a:rPr lang="en-US" sz="1050" kern="0" dirty="0">
                 <a:solidFill>
                   <a:srgbClr val="ECECEC"/>
                 </a:solidFill>
@@ -22340,7 +22383,7 @@
               </a:rPr>
               <a:t>re-request any missed fill</a:t>
             </a:r>
-            <a:endParaRPr lang="en-US"/>
+            <a:endParaRPr lang="en-US" sz="2000" dirty="0"/>
           </a:p>
           <a:p>
             <a:pPr marL="0" indent="0" algn="l">
@@ -22352,7 +22395,7 @@
               </a:spcBef>
               <a:buNone/>
             </a:pPr>
-            <a:endParaRPr lang="en-US"/>
+            <a:endParaRPr lang="en-US" sz="2000" dirty="0"/>
           </a:p>
           <a:p>
             <a:pPr marL="0" indent="0" algn="l">
@@ -22365,7 +22408,7 @@
               <a:buNone/>
             </a:pPr>
             <a:r>
-              <a:rPr lang="en-US" sz="1000" kern="0">
+              <a:rPr lang="en-US" sz="1050" kern="0" dirty="0">
                 <a:solidFill>
                   <a:srgbClr val="B4B4BE"/>
                 </a:solidFill>
@@ -22375,7 +22418,7 @@
               </a:rPr>
               <a:t>Bound lazily at engine start</a:t>
             </a:r>
-            <a:endParaRPr lang="en-US"/>
+            <a:endParaRPr lang="en-US" sz="2000" dirty="0"/>
           </a:p>
         </p:txBody>
       </p:sp>
@@ -22484,7 +22527,7 @@
               <a:buNone/>
             </a:pPr>
             <a:r>
-              <a:rPr lang="en-US" sz="1000" b="1" kern="0" spc="100">
+              <a:rPr lang="en-US" sz="1400" b="1" kern="0" spc="100">
                 <a:solidFill>
                   <a:srgbClr val="F2860D"/>
                 </a:solidFill>
@@ -22494,7 +22537,7 @@
               </a:rPr>
               <a:t>AUDIT TRAIL</a:t>
             </a:r>
-            <a:endParaRPr lang="en-US"/>
+            <a:endParaRPr lang="en-US" sz="3200"/>
           </a:p>
         </p:txBody>
       </p:sp>
@@ -22529,7 +22572,7 @@
               <a:buNone/>
             </a:pPr>
             <a:r>
-              <a:rPr lang="en-US" sz="1000" b="1" kern="0">
+              <a:rPr lang="en-US" sz="1200" b="1" kern="0" dirty="0">
                 <a:solidFill>
                   <a:srgbClr val="F2860D"/>
                 </a:solidFill>
@@ -22539,7 +22582,7 @@
               </a:rPr>
               <a:t>pm-audit  ·  SUB :5556</a:t>
             </a:r>
-            <a:endParaRPr lang="en-US"/>
+            <a:endParaRPr lang="en-US" sz="2800" dirty="0"/>
           </a:p>
           <a:p>
             <a:pPr marL="0" indent="0" algn="l">
@@ -22552,7 +22595,7 @@
               <a:buNone/>
             </a:pPr>
             <a:r>
-              <a:rPr lang="en-US" sz="1000" kern="0">
+              <a:rPr lang="en-US" sz="1100" kern="0" dirty="0">
                 <a:solidFill>
                   <a:srgbClr val="ECECEC"/>
                 </a:solidFill>
@@ -22562,7 +22605,7 @@
               </a:rPr>
               <a:t>Passive logger of every</a:t>
             </a:r>
-            <a:endParaRPr lang="en-US"/>
+            <a:endParaRPr lang="en-US" sz="2400" dirty="0"/>
           </a:p>
           <a:p>
             <a:pPr marL="0" indent="0" algn="l">
@@ -22575,7 +22618,7 @@
               <a:buNone/>
             </a:pPr>
             <a:r>
-              <a:rPr lang="en-US" sz="1000" kern="0">
+              <a:rPr lang="en-US" sz="1100" kern="0" dirty="0">
                 <a:solidFill>
                   <a:srgbClr val="ECECEC"/>
                 </a:solidFill>
@@ -22585,7 +22628,7 @@
               </a:rPr>
               <a:t>topic and payload</a:t>
             </a:r>
-            <a:endParaRPr lang="en-US"/>
+            <a:endParaRPr lang="en-US" sz="2400" dirty="0"/>
           </a:p>
           <a:p>
             <a:pPr marL="0" indent="0" algn="l">
@@ -22598,7 +22641,7 @@
               <a:buNone/>
             </a:pPr>
             <a:r>
-              <a:rPr lang="en-US" sz="1000" kern="0">
+              <a:rPr lang="en-US" sz="1050" kern="0" dirty="0">
                 <a:solidFill>
                   <a:srgbClr val="B4B4BE"/>
                 </a:solidFill>
@@ -22606,9 +22649,20 @@
                 <a:ea typeface="Courier New" pitchFamily="34" charset="-122"/>
                 <a:cs typeface="Courier New" pitchFamily="34" charset="-120"/>
               </a:rPr>
-              <a:t>data/audit.log</a:t>
-            </a:r>
-            <a:endParaRPr lang="en-US"/>
+              <a:t>data/</a:t>
+            </a:r>
+            <a:r>
+              <a:rPr lang="en-US" sz="1050" kern="0" dirty="0" err="1">
+                <a:solidFill>
+                  <a:srgbClr val="B4B4BE"/>
+                </a:solidFill>
+                <a:latin typeface="Courier New" pitchFamily="34" charset="0"/>
+                <a:ea typeface="Courier New" pitchFamily="34" charset="-122"/>
+                <a:cs typeface="Courier New" pitchFamily="34" charset="-120"/>
+              </a:rPr>
+              <a:t>audit.log</a:t>
+            </a:r>
+            <a:endParaRPr lang="en-US" sz="2000" dirty="0"/>
           </a:p>
           <a:p>
             <a:pPr marL="0" indent="0" algn="l">
@@ -22621,7 +22675,7 @@
               <a:buNone/>
             </a:pPr>
             <a:r>
-              <a:rPr lang="en-US" sz="1000" kern="0">
+              <a:rPr lang="en-US" sz="1050" kern="0" dirty="0">
                 <a:solidFill>
                   <a:srgbClr val="B4B4BE"/>
                 </a:solidFill>
@@ -22631,7 +22685,7 @@
               </a:rPr>
               <a:t>[TS] [TOPIC] {JSON}</a:t>
             </a:r>
-            <a:endParaRPr lang="en-US"/>
+            <a:endParaRPr lang="en-US" sz="2000" dirty="0"/>
           </a:p>
           <a:p>
             <a:pPr marL="0" indent="0" algn="l">
@@ -22643,7 +22697,7 @@
               </a:spcBef>
               <a:buNone/>
             </a:pPr>
-            <a:endParaRPr lang="en-US"/>
+            <a:endParaRPr lang="en-US" sz="2000" dirty="0"/>
           </a:p>
           <a:p>
             <a:pPr marL="0" indent="0" algn="l">
@@ -22656,7 +22710,7 @@
               <a:buNone/>
             </a:pPr>
             <a:r>
-              <a:rPr lang="en-US" sz="1000" kern="0">
+              <a:rPr lang="en-US" sz="1050" kern="0" dirty="0">
                 <a:solidFill>
                   <a:srgbClr val="B4B4BE"/>
                 </a:solidFill>
@@ -22664,9 +22718,31 @@
                 <a:ea typeface="Calibri" pitchFamily="34" charset="-122"/>
                 <a:cs typeface="Calibri" pitchFamily="34" charset="-120"/>
               </a:rPr>
-              <a:t>Authoritative, replayable record</a:t>
-            </a:r>
-            <a:endParaRPr lang="en-US"/>
+              <a:t>Authoritative, </a:t>
+            </a:r>
+            <a:r>
+              <a:rPr lang="en-US" sz="1050" kern="0" dirty="0" err="1">
+                <a:solidFill>
+                  <a:srgbClr val="B4B4BE"/>
+                </a:solidFill>
+                <a:latin typeface="Calibri" pitchFamily="34" charset="0"/>
+                <a:ea typeface="Calibri" pitchFamily="34" charset="-122"/>
+                <a:cs typeface="Calibri" pitchFamily="34" charset="-120"/>
+              </a:rPr>
+              <a:t>replayable</a:t>
+            </a:r>
+            <a:r>
+              <a:rPr lang="en-US" sz="1050" kern="0" dirty="0">
+                <a:solidFill>
+                  <a:srgbClr val="B4B4BE"/>
+                </a:solidFill>
+                <a:latin typeface="Calibri" pitchFamily="34" charset="0"/>
+                <a:ea typeface="Calibri" pitchFamily="34" charset="-122"/>
+                <a:cs typeface="Calibri" pitchFamily="34" charset="-120"/>
+              </a:rPr>
+              <a:t> record</a:t>
+            </a:r>
+            <a:endParaRPr lang="en-US" sz="2000" dirty="0"/>
           </a:p>
         </p:txBody>
       </p:sp>
@@ -22775,7 +22851,7 @@
               <a:buNone/>
             </a:pPr>
             <a:r>
-              <a:rPr lang="en-US" sz="1000" b="1" kern="0" spc="100">
+              <a:rPr lang="en-US" sz="1400" b="1" kern="0" spc="100">
                 <a:solidFill>
                   <a:srgbClr val="5B9BF5"/>
                 </a:solidFill>
@@ -22785,7 +22861,7 @@
               </a:rPr>
               <a:t>CLEARING</a:t>
             </a:r>
-            <a:endParaRPr lang="en-US"/>
+            <a:endParaRPr lang="en-US" sz="3200"/>
           </a:p>
         </p:txBody>
       </p:sp>
@@ -22798,7 +22874,7 @@
         <p:spPr>
           <a:xfrm>
             <a:off x="6183690" y="2160000"/>
-            <a:ext cx="2243381" cy="1965000"/>
+            <a:ext cx="2403719" cy="1965000"/>
           </a:xfrm>
           <a:prstGeom prst="rect">
             <a:avLst/>
@@ -22820,7 +22896,7 @@
               <a:buNone/>
             </a:pPr>
             <a:r>
-              <a:rPr lang="en-US" sz="1000" b="1" kern="0">
+              <a:rPr lang="en-US" sz="1200" b="1" kern="0" dirty="0">
                 <a:solidFill>
                   <a:srgbClr val="5B9BF5"/>
                 </a:solidFill>
@@ -22830,7 +22906,7 @@
               </a:rPr>
               <a:t>pm-clearing  ·  SUB :5556</a:t>
             </a:r>
-            <a:endParaRPr lang="en-US"/>
+            <a:endParaRPr lang="en-US" sz="2800" dirty="0"/>
           </a:p>
           <a:p>
             <a:pPr marL="0" indent="0" algn="l">
@@ -22843,7 +22919,7 @@
               <a:buNone/>
             </a:pPr>
             <a:r>
-              <a:rPr lang="en-US" sz="1000" kern="0">
+              <a:rPr lang="en-US" sz="1100" kern="0" dirty="0">
                 <a:solidFill>
                   <a:srgbClr val="ECECEC"/>
                 </a:solidFill>
@@ -22853,7 +22929,7 @@
               </a:rPr>
               <a:t>Settlement + VWAP P&amp;L</a:t>
             </a:r>
-            <a:endParaRPr lang="en-US"/>
+            <a:endParaRPr lang="en-US" sz="2400" dirty="0"/>
           </a:p>
           <a:p>
             <a:pPr marL="0" indent="0" algn="l">
@@ -22866,7 +22942,7 @@
               <a:buNone/>
             </a:pPr>
             <a:r>
-              <a:rPr lang="en-US" sz="1000" kern="0">
+              <a:rPr lang="en-US" sz="1100" kern="0" dirty="0">
                 <a:solidFill>
                   <a:srgbClr val="ECECEC"/>
                 </a:solidFill>
@@ -22876,7 +22952,7 @@
               </a:rPr>
               <a:t>per gateway</a:t>
             </a:r>
-            <a:endParaRPr lang="en-US"/>
+            <a:endParaRPr lang="en-US" sz="2400" dirty="0"/>
           </a:p>
           <a:p>
             <a:pPr marL="0" indent="0" algn="l">
@@ -22889,7 +22965,7 @@
               <a:buNone/>
             </a:pPr>
             <a:r>
-              <a:rPr lang="en-US" sz="1000" kern="0">
+              <a:rPr lang="en-US" sz="1050" kern="0" dirty="0">
                 <a:solidFill>
                   <a:srgbClr val="B4B4BE"/>
                 </a:solidFill>
@@ -22897,9 +22973,20 @@
                 <a:ea typeface="Courier New" pitchFamily="34" charset="-122"/>
                 <a:cs typeface="Courier New" pitchFamily="34" charset="-120"/>
               </a:rPr>
-              <a:t>data/clearing.db</a:t>
-            </a:r>
-            <a:endParaRPr lang="en-US"/>
+              <a:t>data/</a:t>
+            </a:r>
+            <a:r>
+              <a:rPr lang="en-US" sz="1050" kern="0" dirty="0" err="1">
+                <a:solidFill>
+                  <a:srgbClr val="B4B4BE"/>
+                </a:solidFill>
+                <a:latin typeface="Courier New" pitchFamily="34" charset="0"/>
+                <a:ea typeface="Courier New" pitchFamily="34" charset="-122"/>
+                <a:cs typeface="Courier New" pitchFamily="34" charset="-120"/>
+              </a:rPr>
+              <a:t>clearing.db</a:t>
+            </a:r>
+            <a:endParaRPr lang="en-US" sz="2000" dirty="0"/>
           </a:p>
           <a:p>
             <a:pPr marL="0" indent="0" algn="l">
@@ -22911,7 +22998,7 @@
               </a:spcBef>
               <a:buNone/>
             </a:pPr>
-            <a:endParaRPr lang="en-US"/>
+            <a:endParaRPr lang="en-US" sz="2000" dirty="0"/>
           </a:p>
           <a:p>
             <a:pPr marL="0" indent="0" algn="l">
@@ -22924,7 +23011,7 @@
               <a:buNone/>
             </a:pPr>
             <a:r>
-              <a:rPr lang="en-US" sz="1000" kern="0">
+              <a:rPr lang="en-US" sz="1050" kern="0" dirty="0">
                 <a:solidFill>
                   <a:srgbClr val="B4B4BE"/>
                 </a:solidFill>
@@ -22934,20 +23021,12 @@
               </a:rPr>
               <a:t>Realized &amp; unrealized</a:t>
             </a:r>
-            <a:endParaRPr lang="en-US"/>
-          </a:p>
-          <a:p>
-            <a:pPr marL="0" indent="0" algn="l">
-              <a:lnSpc>
-                <a:spcPct val="124000"/>
-              </a:lnSpc>
-              <a:spcBef>
-                <a:spcPts val="200"/>
-              </a:spcBef>
-              <a:buNone/>
-            </a:pPr>
-            <a:r>
-              <a:rPr lang="en-US" sz="1000" kern="0">
+            <a:r>
+              <a:rPr lang="en-US" sz="2000" dirty="0"/>
+              <a:t> </a:t>
+            </a:r>
+            <a:r>
+              <a:rPr lang="en-US" sz="1050" kern="0" dirty="0">
                 <a:solidFill>
                   <a:srgbClr val="B4B4BE"/>
                 </a:solidFill>
@@ -22957,7 +23036,7 @@
               </a:rPr>
               <a:t>positions persisted</a:t>
             </a:r>
-            <a:endParaRPr lang="en-US"/>
+            <a:endParaRPr lang="en-US" sz="2000" dirty="0"/>
           </a:p>
         </p:txBody>
       </p:sp>
@@ -22992,6 +23071,14 @@
             </a:solidFill>
             <a:prstDash val="solid"/>
           </a:ln>
+          <a:effectLst>
+            <a:glow rad="63500">
+              <a:schemeClr val="accent4">
+                <a:satMod val="175000"/>
+                <a:alpha val="40000"/>
+              </a:schemeClr>
+            </a:glow>
+          </a:effectLst>
         </p:spPr>
         <p:txBody>
           <a:bodyPr/>
@@ -23029,7 +23116,7 @@
               <a:buNone/>
             </a:pPr>
             <a:r>
-              <a:rPr lang="en-US" sz="1000" kern="0">
+              <a:rPr lang="en-US" sz="1200" kern="0" dirty="0">
                 <a:solidFill>
                   <a:srgbClr val="ECECEC"/>
                 </a:solidFill>
@@ -23039,7 +23126,7 @@
               </a:rPr>
               <a:t>None of these can alter the book — they only subscribe. The audit log is the single source of truth for reconstructing exactly what happened in a session.</a:t>
             </a:r>
-            <a:endParaRPr lang="en-US"/>
+            <a:endParaRPr lang="en-US" sz="2800" dirty="0"/>
           </a:p>
         </p:txBody>
       </p:sp>
@@ -23052,7 +23139,7 @@
         <p:spPr>
           <a:xfrm>
             <a:off x="566928" y="4791456"/>
-            <a:ext cx="5486400" cy="256032"/>
+            <a:ext cx="2820328" cy="256032"/>
           </a:xfrm>
           <a:prstGeom prst="rect">
             <a:avLst/>

</xml_diff>

<commit_message>
docs(pres): add spy clients and dc-gwy
</commit_message>
<xml_diff>
--- a/docs/presentations/introduction-to-edumatcher.pptx
+++ b/docs/presentations/introduction-to-edumatcher.pptx
@@ -40275,7 +40275,7 @@
         <p:spPr>
           <a:xfrm>
             <a:off x="786384" y="329184"/>
-            <a:ext cx="7315200" cy="274320"/>
+            <a:ext cx="3405788" cy="274320"/>
           </a:xfrm>
           <a:prstGeom prst="rect">
             <a:avLst/>
@@ -40342,7 +40342,7 @@
                 <a:ea typeface="Arial" pitchFamily="34" charset="-122"/>
                 <a:cs typeface="Arial" pitchFamily="34" charset="-120"/>
               </a:rPr>
-              <a:t>The ZeroMQ message bus</a:t>
+              <a:t>The ZeroMQ message bus </a:t>
             </a:r>
             <a:endParaRPr lang="en-US" sz="2900" dirty="0"/>
           </a:p>
@@ -40596,7 +40596,7 @@
         </p:nvSpPr>
         <p:spPr>
           <a:xfrm>
-            <a:off x="566928" y="1517904"/>
+            <a:off x="580996" y="1257651"/>
             <a:ext cx="1783080" cy="749808"/>
           </a:xfrm>
           <a:prstGeom prst="roundRect">
@@ -40643,7 +40643,7 @@
         </p:nvSpPr>
         <p:spPr>
           <a:xfrm>
-            <a:off x="566928" y="1517904"/>
+            <a:off x="580996" y="1257651"/>
             <a:ext cx="1783080" cy="54864"/>
           </a:xfrm>
           <a:prstGeom prst="rect">
@@ -40670,7 +40670,7 @@
         </p:nvSpPr>
         <p:spPr>
           <a:xfrm>
-            <a:off x="658368" y="1627632"/>
+            <a:off x="672436" y="1367379"/>
             <a:ext cx="1600200" cy="310896"/>
           </a:xfrm>
           <a:prstGeom prst="rect">
@@ -40709,7 +40709,7 @@
         </p:nvSpPr>
         <p:spPr>
           <a:xfrm>
-            <a:off x="640080" y="1920240"/>
+            <a:off x="654148" y="1659987"/>
             <a:ext cx="1636776" cy="310896"/>
           </a:xfrm>
           <a:prstGeom prst="rect">
@@ -40754,8 +40754,8 @@
         </p:nvSpPr>
         <p:spPr>
           <a:xfrm>
-            <a:off x="2350008" y="1892808"/>
-            <a:ext cx="1170432" cy="964692"/>
+            <a:off x="2364076" y="1632554"/>
+            <a:ext cx="1159881" cy="1209119"/>
           </a:xfrm>
           <a:prstGeom prst="line">
             <a:avLst/>
@@ -40791,7 +40791,7 @@
         </p:nvSpPr>
         <p:spPr>
           <a:xfrm>
-            <a:off x="566928" y="2487168"/>
+            <a:off x="580996" y="2226915"/>
             <a:ext cx="1783080" cy="749808"/>
           </a:xfrm>
           <a:prstGeom prst="roundRect">
@@ -40838,7 +40838,7 @@
         </p:nvSpPr>
         <p:spPr>
           <a:xfrm>
-            <a:off x="566928" y="2487168"/>
+            <a:off x="580996" y="2226915"/>
             <a:ext cx="1783080" cy="54864"/>
           </a:xfrm>
           <a:prstGeom prst="rect">
@@ -40865,7 +40865,7 @@
         </p:nvSpPr>
         <p:spPr>
           <a:xfrm>
-            <a:off x="658368" y="2596896"/>
+            <a:off x="672436" y="2336643"/>
             <a:ext cx="1600200" cy="310896"/>
           </a:xfrm>
           <a:prstGeom prst="rect">
@@ -40904,7 +40904,7 @@
         </p:nvSpPr>
         <p:spPr>
           <a:xfrm>
-            <a:off x="640080" y="2889504"/>
+            <a:off x="654148" y="2629251"/>
             <a:ext cx="1636776" cy="310896"/>
           </a:xfrm>
           <a:prstGeom prst="rect">
@@ -40948,9 +40948,9 @@
           <p:nvPr/>
         </p:nvSpPr>
         <p:spPr>
-          <a:xfrm flipV="1">
-            <a:off x="2350008" y="2857500"/>
-            <a:ext cx="1170432" cy="4572"/>
+          <a:xfrm>
+            <a:off x="2364075" y="2601818"/>
+            <a:ext cx="1173949" cy="275025"/>
           </a:xfrm>
           <a:prstGeom prst="line">
             <a:avLst/>
@@ -40986,7 +40986,7 @@
         </p:nvSpPr>
         <p:spPr>
           <a:xfrm>
-            <a:off x="566928" y="3456432"/>
+            <a:off x="580996" y="3196179"/>
             <a:ext cx="1783080" cy="749808"/>
           </a:xfrm>
           <a:prstGeom prst="roundRect">
@@ -41033,7 +41033,7 @@
         </p:nvSpPr>
         <p:spPr>
           <a:xfrm>
-            <a:off x="566928" y="3456432"/>
+            <a:off x="580996" y="3196179"/>
             <a:ext cx="1783080" cy="54864"/>
           </a:xfrm>
           <a:prstGeom prst="rect">
@@ -41060,7 +41060,7 @@
         </p:nvSpPr>
         <p:spPr>
           <a:xfrm>
-            <a:off x="658368" y="3566160"/>
+            <a:off x="672436" y="3305907"/>
             <a:ext cx="1600200" cy="310896"/>
           </a:xfrm>
           <a:prstGeom prst="rect">
@@ -41099,7 +41099,7 @@
         </p:nvSpPr>
         <p:spPr>
           <a:xfrm>
-            <a:off x="640080" y="3858768"/>
+            <a:off x="654148" y="3598515"/>
             <a:ext cx="1636776" cy="310896"/>
           </a:xfrm>
           <a:prstGeom prst="rect">
@@ -41144,8 +41144,8 @@
         </p:nvSpPr>
         <p:spPr>
           <a:xfrm flipV="1">
-            <a:off x="2350008" y="2857500"/>
-            <a:ext cx="1170432" cy="973836"/>
+            <a:off x="2364076" y="2883876"/>
+            <a:ext cx="1180982" cy="687205"/>
           </a:xfrm>
           <a:prstGeom prst="line">
             <a:avLst/>
@@ -41639,45 +41639,6 @@
       </p:sp>
       <p:sp>
         <p:nvSpPr>
-          <p:cNvPr id="38" name="Text 36"/>
-          <p:cNvSpPr/>
-          <p:nvPr/>
-        </p:nvSpPr>
-        <p:spPr>
-          <a:xfrm>
-            <a:off x="6885432" y="3566160"/>
-            <a:ext cx="1600200" cy="310896"/>
-          </a:xfrm>
-          <a:prstGeom prst="rect">
-            <a:avLst/>
-          </a:prstGeom>
-          <a:noFill/>
-          <a:ln/>
-        </p:spPr>
-        <p:txBody>
-          <a:bodyPr wrap="square" lIns="0" tIns="0" rIns="0" bIns="0" rtlCol="0" anchor="ctr"/>
-          <a:lstStyle/>
-          <a:p>
-            <a:pPr marL="0" indent="0" algn="ctr">
-              <a:buNone/>
-            </a:pPr>
-            <a:r>
-              <a:rPr lang="en-US" sz="1150" b="1" dirty="0">
-                <a:solidFill>
-                  <a:srgbClr val="ECECEC"/>
-                </a:solidFill>
-                <a:latin typeface="Courier New" pitchFamily="34" charset="0"/>
-                <a:ea typeface="Courier New" pitchFamily="34" charset="-122"/>
-                <a:cs typeface="Courier New" pitchFamily="34" charset="-120"/>
-              </a:rPr>
-              <a:t>Drop-copy :5557</a:t>
-            </a:r>
-            <a:endParaRPr lang="en-US" sz="1150" dirty="0"/>
-          </a:p>
-        </p:txBody>
-      </p:sp>
-      <p:sp>
-        <p:nvSpPr>
           <p:cNvPr id="39" name="Text 37"/>
           <p:cNvSpPr/>
           <p:nvPr/>
@@ -41931,8 +41892,8 @@
         </p:nvSpPr>
         <p:spPr>
           <a:xfrm>
-            <a:off x="2935224" y="4400045"/>
-            <a:ext cx="146304" cy="91440"/>
+            <a:off x="3387502" y="4221783"/>
+            <a:ext cx="45719" cy="274320"/>
           </a:xfrm>
           <a:prstGeom prst="rect">
             <a:avLst/>
@@ -41958,8 +41919,8 @@
         </p:nvSpPr>
         <p:spPr>
           <a:xfrm>
-            <a:off x="396685" y="4276793"/>
-            <a:ext cx="2468880" cy="274320"/>
+            <a:off x="2644728" y="3840480"/>
+            <a:ext cx="572531" cy="822960"/>
           </a:xfrm>
           <a:prstGeom prst="rect">
             <a:avLst/>
@@ -42003,8 +41964,8 @@
         </p:nvSpPr>
         <p:spPr>
           <a:xfrm>
-            <a:off x="5927615" y="4394840"/>
-            <a:ext cx="146304" cy="91440"/>
+            <a:off x="5604057" y="4183825"/>
+            <a:ext cx="45719" cy="275634"/>
           </a:xfrm>
           <a:prstGeom prst="rect">
             <a:avLst/>
@@ -42030,8 +41991,8 @@
         </p:nvSpPr>
         <p:spPr>
           <a:xfrm>
-            <a:off x="6137927" y="4297676"/>
-            <a:ext cx="2926080" cy="274320"/>
+            <a:off x="5814369" y="4086661"/>
+            <a:ext cx="945156" cy="534576"/>
           </a:xfrm>
           <a:prstGeom prst="rect">
             <a:avLst/>
@@ -42452,6 +42413,545 @@
           <a:ln w="50800">
             <a:solidFill>
               <a:srgbClr val="8FA0B0"/>
+            </a:solidFill>
+            <a:prstDash val="solid"/>
+            <a:tailEnd type="triangle"/>
+          </a:ln>
+        </p:spPr>
+        <p:txBody>
+          <a:bodyPr/>
+          <a:lstStyle/>
+          <a:p>
+            <a:endParaRPr lang="en-SE"/>
+          </a:p>
+        </p:txBody>
+      </p:sp>
+      <p:sp>
+        <p:nvSpPr>
+          <p:cNvPr id="56" name="Text 31">
+            <a:extLst>
+              <a:ext uri="{FF2B5EF4-FFF2-40B4-BE49-F238E27FC236}">
+                <a16:creationId xmlns:a16="http://schemas.microsoft.com/office/drawing/2014/main" id="{80F22B7E-6D18-3503-FD7B-21AC11DDE148}"/>
+              </a:ext>
+            </a:extLst>
+          </p:cNvPr>
+          <p:cNvSpPr/>
+          <p:nvPr/>
+        </p:nvSpPr>
+        <p:spPr>
+          <a:xfrm>
+            <a:off x="6858927" y="3537800"/>
+            <a:ext cx="1600200" cy="310896"/>
+          </a:xfrm>
+          <a:prstGeom prst="rect">
+            <a:avLst/>
+          </a:prstGeom>
+          <a:noFill/>
+          <a:ln/>
+        </p:spPr>
+        <p:txBody>
+          <a:bodyPr wrap="square" lIns="0" tIns="0" rIns="0" bIns="0" rtlCol="0" anchor="ctr"/>
+          <a:lstStyle/>
+          <a:p>
+            <a:pPr marL="0" indent="0" algn="ctr">
+              <a:buNone/>
+            </a:pPr>
+            <a:r>
+              <a:rPr lang="en-US" sz="1150" b="1" dirty="0">
+                <a:solidFill>
+                  <a:srgbClr val="ECECEC"/>
+                </a:solidFill>
+                <a:latin typeface="Courier New" pitchFamily="34" charset="0"/>
+                <a:ea typeface="Courier New" pitchFamily="34" charset="-122"/>
+                <a:cs typeface="Courier New" pitchFamily="34" charset="-120"/>
+              </a:rPr>
+              <a:t>pm-dc-</a:t>
+            </a:r>
+            <a:r>
+              <a:rPr lang="en-US" sz="1150" b="1" dirty="0" err="1">
+                <a:solidFill>
+                  <a:srgbClr val="ECECEC"/>
+                </a:solidFill>
+                <a:latin typeface="Courier New" pitchFamily="34" charset="0"/>
+                <a:ea typeface="Courier New" pitchFamily="34" charset="-122"/>
+                <a:cs typeface="Courier New" pitchFamily="34" charset="-120"/>
+              </a:rPr>
+              <a:t>gwy</a:t>
+            </a:r>
+            <a:endParaRPr lang="en-US" sz="1150" dirty="0"/>
+          </a:p>
+        </p:txBody>
+      </p:sp>
+      <p:sp>
+        <p:nvSpPr>
+          <p:cNvPr id="60" name="bus link">
+            <a:extLst>
+              <a:ext uri="{FF2B5EF4-FFF2-40B4-BE49-F238E27FC236}">
+                <a16:creationId xmlns:a16="http://schemas.microsoft.com/office/drawing/2014/main" id="{6B2297DA-31BA-AF39-B2F9-642C45E77C58}"/>
+              </a:ext>
+              <a:ext uri="{C183D7F6-B498-43B3-948B-1728B52AA6E4}">
+                <adec:decorative xmlns:adec="http://schemas.microsoft.com/office/drawing/2017/decorative" val="1"/>
+              </a:ext>
+            </a:extLst>
+          </p:cNvPr>
+          <p:cNvSpPr/>
+          <p:nvPr/>
+        </p:nvSpPr>
+        <p:spPr>
+          <a:xfrm flipV="1">
+            <a:off x="5634111" y="954156"/>
+            <a:ext cx="1124497" cy="1894551"/>
+          </a:xfrm>
+          <a:prstGeom prst="line">
+            <a:avLst/>
+          </a:prstGeom>
+          <a:noFill/>
+          <a:ln w="22225">
+            <a:solidFill>
+              <a:srgbClr val="4FB3CC"/>
+            </a:solidFill>
+            <a:prstDash val="solid"/>
+            <a:tailEnd type="triangle"/>
+          </a:ln>
+        </p:spPr>
+        <p:txBody>
+          <a:bodyPr/>
+          <a:lstStyle/>
+          <a:p>
+            <a:endParaRPr lang="en-SE"/>
+          </a:p>
+        </p:txBody>
+      </p:sp>
+      <p:sp>
+        <p:nvSpPr>
+          <p:cNvPr id="61" name="card">
+            <a:extLst>
+              <a:ext uri="{FF2B5EF4-FFF2-40B4-BE49-F238E27FC236}">
+                <a16:creationId xmlns:a16="http://schemas.microsoft.com/office/drawing/2014/main" id="{B6DE629E-D10E-46F9-A93E-8FCA2733A80A}"/>
+              </a:ext>
+              <a:ext uri="{C183D7F6-B498-43B3-948B-1728B52AA6E4}">
+                <adec:decorative xmlns:adec="http://schemas.microsoft.com/office/drawing/2017/decorative" val="1"/>
+              </a:ext>
+            </a:extLst>
+          </p:cNvPr>
+          <p:cNvSpPr/>
+          <p:nvPr/>
+        </p:nvSpPr>
+        <p:spPr>
+          <a:xfrm>
+            <a:off x="6780740" y="537243"/>
+            <a:ext cx="1783080" cy="749808"/>
+          </a:xfrm>
+          <a:prstGeom prst="roundRect">
+            <a:avLst>
+              <a:gd name="adj" fmla="val 7317"/>
+            </a:avLst>
+          </a:prstGeom>
+          <a:solidFill>
+            <a:srgbClr val="26262D"/>
+          </a:solidFill>
+          <a:ln w="12700">
+            <a:solidFill>
+              <a:srgbClr val="3B3B46"/>
+            </a:solidFill>
+            <a:prstDash val="solid"/>
+          </a:ln>
+          <a:effectLst>
+            <a:outerShdw blurRad="114300" dist="38100" dir="5400000" algn="bl" rotWithShape="0">
+              <a:srgbClr val="000000">
+                <a:alpha val="35000"/>
+              </a:srgbClr>
+            </a:outerShdw>
+          </a:effectLst>
+        </p:spPr>
+        <p:txBody>
+          <a:bodyPr/>
+          <a:lstStyle/>
+          <a:p>
+            <a:endParaRPr lang="en-SE"/>
+          </a:p>
+        </p:txBody>
+      </p:sp>
+      <p:sp>
+        <p:nvSpPr>
+          <p:cNvPr id="62" name="node accent">
+            <a:extLst>
+              <a:ext uri="{FF2B5EF4-FFF2-40B4-BE49-F238E27FC236}">
+                <a16:creationId xmlns:a16="http://schemas.microsoft.com/office/drawing/2014/main" id="{1E6C6139-D94B-739E-506C-F40A2F34CE3F}"/>
+              </a:ext>
+              <a:ext uri="{C183D7F6-B498-43B3-948B-1728B52AA6E4}">
+                <adec:decorative xmlns:adec="http://schemas.microsoft.com/office/drawing/2017/decorative" val="1"/>
+              </a:ext>
+            </a:extLst>
+          </p:cNvPr>
+          <p:cNvSpPr/>
+          <p:nvPr/>
+        </p:nvSpPr>
+        <p:spPr>
+          <a:xfrm>
+            <a:off x="6780740" y="537243"/>
+            <a:ext cx="1783080" cy="54864"/>
+          </a:xfrm>
+          <a:prstGeom prst="rect">
+            <a:avLst/>
+          </a:prstGeom>
+          <a:solidFill>
+            <a:srgbClr val="4FB3CC"/>
+          </a:solidFill>
+          <a:ln/>
+        </p:spPr>
+        <p:txBody>
+          <a:bodyPr/>
+          <a:lstStyle/>
+          <a:p>
+            <a:endParaRPr lang="en-SE"/>
+          </a:p>
+        </p:txBody>
+      </p:sp>
+      <p:sp>
+        <p:nvSpPr>
+          <p:cNvPr id="63" name="Text 26">
+            <a:extLst>
+              <a:ext uri="{FF2B5EF4-FFF2-40B4-BE49-F238E27FC236}">
+                <a16:creationId xmlns:a16="http://schemas.microsoft.com/office/drawing/2014/main" id="{01B0064F-1DC4-47EF-093F-23A0C7BC38EB}"/>
+              </a:ext>
+            </a:extLst>
+          </p:cNvPr>
+          <p:cNvSpPr/>
+          <p:nvPr/>
+        </p:nvSpPr>
+        <p:spPr>
+          <a:xfrm>
+            <a:off x="6872180" y="646971"/>
+            <a:ext cx="1600200" cy="310896"/>
+          </a:xfrm>
+          <a:prstGeom prst="rect">
+            <a:avLst/>
+          </a:prstGeom>
+          <a:noFill/>
+          <a:ln/>
+        </p:spPr>
+        <p:txBody>
+          <a:bodyPr wrap="square" lIns="0" tIns="0" rIns="0" bIns="0" rtlCol="0" anchor="ctr"/>
+          <a:lstStyle/>
+          <a:p>
+            <a:pPr marL="0" indent="0" algn="ctr">
+              <a:buNone/>
+            </a:pPr>
+            <a:r>
+              <a:rPr lang="en-US" sz="1150" b="1" dirty="0">
+                <a:solidFill>
+                  <a:srgbClr val="ECECEC"/>
+                </a:solidFill>
+                <a:latin typeface="Courier New" pitchFamily="34" charset="0"/>
+                <a:ea typeface="Courier New" pitchFamily="34" charset="-122"/>
+                <a:cs typeface="Courier New" pitchFamily="34" charset="-120"/>
+              </a:rPr>
+              <a:t>pm-md-</a:t>
+            </a:r>
+            <a:r>
+              <a:rPr lang="en-US" sz="1150" b="1" dirty="0" err="1">
+                <a:solidFill>
+                  <a:srgbClr val="ECECEC"/>
+                </a:solidFill>
+                <a:latin typeface="Courier New" pitchFamily="34" charset="0"/>
+                <a:ea typeface="Courier New" pitchFamily="34" charset="-122"/>
+                <a:cs typeface="Courier New" pitchFamily="34" charset="-120"/>
+              </a:rPr>
+              <a:t>gwy</a:t>
+            </a:r>
+            <a:endParaRPr lang="en-US" sz="1150" dirty="0"/>
+          </a:p>
+        </p:txBody>
+      </p:sp>
+      <p:sp>
+        <p:nvSpPr>
+          <p:cNvPr id="64" name="Text 27">
+            <a:extLst>
+              <a:ext uri="{FF2B5EF4-FFF2-40B4-BE49-F238E27FC236}">
+                <a16:creationId xmlns:a16="http://schemas.microsoft.com/office/drawing/2014/main" id="{3875E0D8-E2B8-B8D2-CEC2-106E6D1A659A}"/>
+              </a:ext>
+            </a:extLst>
+          </p:cNvPr>
+          <p:cNvSpPr/>
+          <p:nvPr/>
+        </p:nvSpPr>
+        <p:spPr>
+          <a:xfrm>
+            <a:off x="6853892" y="939579"/>
+            <a:ext cx="1636776" cy="310896"/>
+          </a:xfrm>
+          <a:prstGeom prst="rect">
+            <a:avLst/>
+          </a:prstGeom>
+          <a:noFill/>
+          <a:ln/>
+        </p:spPr>
+        <p:txBody>
+          <a:bodyPr wrap="square" lIns="0" tIns="0" rIns="0" bIns="0" rtlCol="0" anchor="t"/>
+          <a:lstStyle/>
+          <a:p>
+            <a:pPr marL="0" indent="0" algn="ctr">
+              <a:buNone/>
+            </a:pPr>
+            <a:r>
+              <a:rPr lang="en-US" sz="900" dirty="0">
+                <a:solidFill>
+                  <a:srgbClr val="B4B4BE"/>
+                </a:solidFill>
+                <a:latin typeface="Calibri" pitchFamily="34" charset="0"/>
+                <a:ea typeface="Calibri" pitchFamily="34" charset="-122"/>
+                <a:cs typeface="Calibri" pitchFamily="34" charset="-120"/>
+              </a:rPr>
+              <a:t>Trade &amp; P&amp;L tracker</a:t>
+            </a:r>
+            <a:endParaRPr lang="en-US" sz="900" dirty="0"/>
+          </a:p>
+        </p:txBody>
+      </p:sp>
+      <p:sp>
+        <p:nvSpPr>
+          <p:cNvPr id="65" name="bus link">
+            <a:extLst>
+              <a:ext uri="{FF2B5EF4-FFF2-40B4-BE49-F238E27FC236}">
+                <a16:creationId xmlns:a16="http://schemas.microsoft.com/office/drawing/2014/main" id="{579C1F61-38BA-1890-F978-CD767368189F}"/>
+              </a:ext>
+              <a:ext uri="{C183D7F6-B498-43B3-948B-1728B52AA6E4}">
+                <adec:decorative xmlns:adec="http://schemas.microsoft.com/office/drawing/2017/decorative" val="1"/>
+              </a:ext>
+            </a:extLst>
+          </p:cNvPr>
+          <p:cNvSpPr/>
+          <p:nvPr/>
+        </p:nvSpPr>
+        <p:spPr>
+          <a:xfrm flipH="1" flipV="1">
+            <a:off x="7687993" y="126607"/>
+            <a:ext cx="3921" cy="340491"/>
+          </a:xfrm>
+          <a:prstGeom prst="line">
+            <a:avLst/>
+          </a:prstGeom>
+          <a:noFill/>
+          <a:ln w="22225">
+            <a:solidFill>
+              <a:srgbClr val="4FB3CC"/>
+            </a:solidFill>
+            <a:prstDash val="sysDot"/>
+            <a:tailEnd type="none"/>
+          </a:ln>
+        </p:spPr>
+        <p:txBody>
+          <a:bodyPr/>
+          <a:lstStyle/>
+          <a:p>
+            <a:endParaRPr lang="en-SE"/>
+          </a:p>
+        </p:txBody>
+      </p:sp>
+      <p:sp>
+        <p:nvSpPr>
+          <p:cNvPr id="66" name="card">
+            <a:extLst>
+              <a:ext uri="{FF2B5EF4-FFF2-40B4-BE49-F238E27FC236}">
+                <a16:creationId xmlns:a16="http://schemas.microsoft.com/office/drawing/2014/main" id="{24A7A83D-3722-C3DE-458A-9954D8BC6902}"/>
+              </a:ext>
+              <a:ext uri="{C183D7F6-B498-43B3-948B-1728B52AA6E4}">
+                <adec:decorative xmlns:adec="http://schemas.microsoft.com/office/drawing/2017/decorative" val="1"/>
+              </a:ext>
+            </a:extLst>
+          </p:cNvPr>
+          <p:cNvSpPr/>
+          <p:nvPr/>
+        </p:nvSpPr>
+        <p:spPr>
+          <a:xfrm>
+            <a:off x="578651" y="4133441"/>
+            <a:ext cx="1783080" cy="749808"/>
+          </a:xfrm>
+          <a:prstGeom prst="roundRect">
+            <a:avLst>
+              <a:gd name="adj" fmla="val 7317"/>
+            </a:avLst>
+          </a:prstGeom>
+          <a:solidFill>
+            <a:srgbClr val="26262D"/>
+          </a:solidFill>
+          <a:ln w="12700">
+            <a:solidFill>
+              <a:srgbClr val="3B3B46"/>
+            </a:solidFill>
+            <a:prstDash val="solid"/>
+          </a:ln>
+          <a:effectLst>
+            <a:outerShdw blurRad="114300" dist="38100" dir="5400000" algn="bl" rotWithShape="0">
+              <a:srgbClr val="000000">
+                <a:alpha val="35000"/>
+              </a:srgbClr>
+            </a:outerShdw>
+          </a:effectLst>
+        </p:spPr>
+        <p:txBody>
+          <a:bodyPr/>
+          <a:lstStyle/>
+          <a:p>
+            <a:endParaRPr lang="en-SE"/>
+          </a:p>
+        </p:txBody>
+      </p:sp>
+      <p:sp>
+        <p:nvSpPr>
+          <p:cNvPr id="67" name="node accent">
+            <a:extLst>
+              <a:ext uri="{FF2B5EF4-FFF2-40B4-BE49-F238E27FC236}">
+                <a16:creationId xmlns:a16="http://schemas.microsoft.com/office/drawing/2014/main" id="{5D9EC73D-FBE5-178C-816A-7D7C473B8C08}"/>
+              </a:ext>
+              <a:ext uri="{C183D7F6-B498-43B3-948B-1728B52AA6E4}">
+                <adec:decorative xmlns:adec="http://schemas.microsoft.com/office/drawing/2017/decorative" val="1"/>
+              </a:ext>
+            </a:extLst>
+          </p:cNvPr>
+          <p:cNvSpPr/>
+          <p:nvPr/>
+        </p:nvSpPr>
+        <p:spPr>
+          <a:xfrm>
+            <a:off x="578651" y="4133441"/>
+            <a:ext cx="1783080" cy="54864"/>
+          </a:xfrm>
+          <a:prstGeom prst="rect">
+            <a:avLst/>
+          </a:prstGeom>
+          <a:solidFill>
+            <a:srgbClr val="F2860D"/>
+          </a:solidFill>
+          <a:ln/>
+        </p:spPr>
+        <p:txBody>
+          <a:bodyPr/>
+          <a:lstStyle/>
+          <a:p>
+            <a:endParaRPr lang="en-SE"/>
+          </a:p>
+        </p:txBody>
+      </p:sp>
+      <p:sp>
+        <p:nvSpPr>
+          <p:cNvPr id="68" name="Text 21">
+            <a:extLst>
+              <a:ext uri="{FF2B5EF4-FFF2-40B4-BE49-F238E27FC236}">
+                <a16:creationId xmlns:a16="http://schemas.microsoft.com/office/drawing/2014/main" id="{F9965C59-47EB-15C8-1F5F-F1A18CAB2AE4}"/>
+              </a:ext>
+            </a:extLst>
+          </p:cNvPr>
+          <p:cNvSpPr/>
+          <p:nvPr/>
+        </p:nvSpPr>
+        <p:spPr>
+          <a:xfrm>
+            <a:off x="670091" y="4243169"/>
+            <a:ext cx="1600200" cy="310896"/>
+          </a:xfrm>
+          <a:prstGeom prst="rect">
+            <a:avLst/>
+          </a:prstGeom>
+          <a:noFill/>
+          <a:ln/>
+        </p:spPr>
+        <p:txBody>
+          <a:bodyPr wrap="square" lIns="0" tIns="0" rIns="0" bIns="0" rtlCol="0" anchor="ctr"/>
+          <a:lstStyle/>
+          <a:p>
+            <a:pPr marL="0" indent="0" algn="ctr">
+              <a:buNone/>
+            </a:pPr>
+            <a:r>
+              <a:rPr lang="en-US" sz="1150" b="1" dirty="0">
+                <a:solidFill>
+                  <a:srgbClr val="ECECEC"/>
+                </a:solidFill>
+                <a:latin typeface="Courier New" pitchFamily="34" charset="0"/>
+                <a:ea typeface="Courier New" pitchFamily="34" charset="-122"/>
+                <a:cs typeface="Courier New" pitchFamily="34" charset="-120"/>
+              </a:rPr>
+              <a:t>pm-admin</a:t>
+            </a:r>
+            <a:endParaRPr lang="en-US" sz="1150" dirty="0"/>
+          </a:p>
+        </p:txBody>
+      </p:sp>
+      <p:sp>
+        <p:nvSpPr>
+          <p:cNvPr id="69" name="Text 22">
+            <a:extLst>
+              <a:ext uri="{FF2B5EF4-FFF2-40B4-BE49-F238E27FC236}">
+                <a16:creationId xmlns:a16="http://schemas.microsoft.com/office/drawing/2014/main" id="{21FB61FB-63C3-4483-1B80-024A4B0D4174}"/>
+              </a:ext>
+            </a:extLst>
+          </p:cNvPr>
+          <p:cNvSpPr/>
+          <p:nvPr/>
+        </p:nvSpPr>
+        <p:spPr>
+          <a:xfrm>
+            <a:off x="651803" y="4535777"/>
+            <a:ext cx="1636776" cy="310896"/>
+          </a:xfrm>
+          <a:prstGeom prst="rect">
+            <a:avLst/>
+          </a:prstGeom>
+          <a:noFill/>
+          <a:ln/>
+        </p:spPr>
+        <p:txBody>
+          <a:bodyPr wrap="square" lIns="0" tIns="0" rIns="0" bIns="0" rtlCol="0" anchor="t"/>
+          <a:lstStyle/>
+          <a:p>
+            <a:pPr marL="0" indent="0" algn="ctr">
+              <a:buNone/>
+            </a:pPr>
+            <a:r>
+              <a:rPr lang="en-US" sz="900" dirty="0">
+                <a:solidFill>
+                  <a:srgbClr val="B4B4BE"/>
+                </a:solidFill>
+                <a:latin typeface="Calibri" pitchFamily="34" charset="0"/>
+                <a:ea typeface="Calibri" pitchFamily="34" charset="-122"/>
+                <a:cs typeface="Calibri" pitchFamily="34" charset="-120"/>
+              </a:rPr>
+              <a:t>HALT / RESUME / STATUS</a:t>
+            </a:r>
+            <a:endParaRPr lang="en-US" sz="900" dirty="0"/>
+          </a:p>
+        </p:txBody>
+      </p:sp>
+      <p:sp>
+        <p:nvSpPr>
+          <p:cNvPr id="70" name="bus link">
+            <a:extLst>
+              <a:ext uri="{FF2B5EF4-FFF2-40B4-BE49-F238E27FC236}">
+                <a16:creationId xmlns:a16="http://schemas.microsoft.com/office/drawing/2014/main" id="{7877CFB5-52AA-F904-2A60-2B924710B2A3}"/>
+              </a:ext>
+              <a:ext uri="{C183D7F6-B498-43B3-948B-1728B52AA6E4}">
+                <adec:decorative xmlns:adec="http://schemas.microsoft.com/office/drawing/2017/decorative" val="1"/>
+              </a:ext>
+            </a:extLst>
+          </p:cNvPr>
+          <p:cNvSpPr/>
+          <p:nvPr/>
+        </p:nvSpPr>
+        <p:spPr>
+          <a:xfrm flipV="1">
+            <a:off x="2375799" y="2855742"/>
+            <a:ext cx="1176293" cy="1669599"/>
+          </a:xfrm>
+          <a:prstGeom prst="line">
+            <a:avLst/>
+          </a:prstGeom>
+          <a:noFill/>
+          <a:ln w="22225">
+            <a:solidFill>
+              <a:srgbClr val="F2860D"/>
             </a:solidFill>
             <a:prstDash val="solid"/>
             <a:tailEnd type="triangle"/>
@@ -46990,8 +47490,8 @@
         </p:nvSpPr>
         <p:spPr>
           <a:xfrm>
-            <a:off x="6291072" y="2011680"/>
-            <a:ext cx="2295144" cy="841248"/>
+            <a:off x="6291072" y="1941340"/>
+            <a:ext cx="2295144" cy="1012874"/>
           </a:xfrm>
           <a:prstGeom prst="rect">
             <a:avLst/>
@@ -47049,14 +47549,13 @@
             <a:endParaRPr lang="en-US" sz="1080" dirty="0"/>
           </a:p>
           <a:p>
-            <a:pPr marL="0" indent="0">
+            <a:pPr>
               <a:lnSpc>
                 <a:spcPct val="102000"/>
               </a:lnSpc>
               <a:spcAft>
                 <a:spcPts val="400"/>
               </a:spcAft>
-              <a:buNone/>
             </a:pPr>
             <a:r>
               <a:rPr lang="en-US" sz="1080" dirty="0">
@@ -47068,6 +47567,67 @@
                 <a:cs typeface="Courier New" pitchFamily="34" charset="-120"/>
               </a:rPr>
               <a:t>pm-index — live index</a:t>
+            </a:r>
+          </a:p>
+          <a:p>
+            <a:pPr>
+              <a:lnSpc>
+                <a:spcPct val="102000"/>
+              </a:lnSpc>
+              <a:spcAft>
+                <a:spcPts val="400"/>
+              </a:spcAft>
+            </a:pPr>
+            <a:r>
+              <a:rPr lang="en-US" sz="1080" dirty="0">
+                <a:solidFill>
+                  <a:srgbClr val="ECECEC"/>
+                </a:solidFill>
+                <a:latin typeface="Courier New" pitchFamily="34" charset="0"/>
+                <a:ea typeface="Courier New" pitchFamily="34" charset="-122"/>
+                <a:cs typeface="Courier New" pitchFamily="34" charset="-120"/>
+              </a:rPr>
+              <a:t>pm-calf-spy — print CALF</a:t>
+            </a:r>
+          </a:p>
+          <a:p>
+            <a:pPr>
+              <a:lnSpc>
+                <a:spcPct val="102000"/>
+              </a:lnSpc>
+              <a:spcAft>
+                <a:spcPts val="400"/>
+              </a:spcAft>
+            </a:pPr>
+            <a:r>
+              <a:rPr lang="en-US" sz="1080" dirty="0">
+                <a:solidFill>
+                  <a:srgbClr val="ECECEC"/>
+                </a:solidFill>
+                <a:latin typeface="Courier New" pitchFamily="34" charset="0"/>
+                <a:cs typeface="Courier New" pitchFamily="34" charset="-120"/>
+              </a:rPr>
+              <a:t>pm-</a:t>
+            </a:r>
+            <a:r>
+              <a:rPr lang="en-US" sz="1080" dirty="0" err="1">
+                <a:solidFill>
+                  <a:srgbClr val="ECECEC"/>
+                </a:solidFill>
+                <a:latin typeface="Courier New" pitchFamily="34" charset="0"/>
+                <a:cs typeface="Courier New" pitchFamily="34" charset="-120"/>
+              </a:rPr>
+              <a:t>ralf</a:t>
+            </a:r>
+            <a:r>
+              <a:rPr lang="en-US" sz="1080" dirty="0">
+                <a:solidFill>
+                  <a:srgbClr val="ECECEC"/>
+                </a:solidFill>
+                <a:latin typeface="Courier New" pitchFamily="34" charset="0"/>
+                <a:cs typeface="Courier New" pitchFamily="34" charset="-120"/>
+              </a:rPr>
+              <a:t>-spy – print RALF</a:t>
             </a:r>
             <a:endParaRPr lang="en-US" sz="1080" dirty="0"/>
           </a:p>
@@ -47410,8 +47970,8 @@
         </p:nvSpPr>
         <p:spPr>
           <a:xfrm>
-            <a:off x="3520440" y="3639312"/>
-            <a:ext cx="2295144" cy="841248"/>
+            <a:off x="3520440" y="3547869"/>
+            <a:ext cx="2295144" cy="1017095"/>
           </a:xfrm>
           <a:prstGeom prst="rect">
             <a:avLst/>
@@ -47489,7 +48049,64 @@
               </a:rPr>
               <a:t>pm-audit — event log</a:t>
             </a:r>
-            <a:endParaRPr lang="en-US" sz="1080" dirty="0"/>
+          </a:p>
+          <a:p>
+            <a:pPr>
+              <a:lnSpc>
+                <a:spcPct val="102000"/>
+              </a:lnSpc>
+              <a:spcAft>
+                <a:spcPts val="400"/>
+              </a:spcAft>
+            </a:pPr>
+            <a:r>
+              <a:rPr lang="en-US" sz="1080" dirty="0">
+                <a:solidFill>
+                  <a:srgbClr val="ECECEC"/>
+                </a:solidFill>
+                <a:latin typeface="Courier New" pitchFamily="34" charset="0"/>
+                <a:cs typeface="Courier New" pitchFamily="34" charset="-120"/>
+              </a:rPr>
+              <a:t>pm-dc-</a:t>
+            </a:r>
+            <a:r>
+              <a:rPr lang="en-US" sz="1080" dirty="0" err="1">
+                <a:solidFill>
+                  <a:srgbClr val="ECECEC"/>
+                </a:solidFill>
+                <a:latin typeface="Courier New" pitchFamily="34" charset="0"/>
+                <a:cs typeface="Courier New" pitchFamily="34" charset="-120"/>
+              </a:rPr>
+              <a:t>gwy</a:t>
+            </a:r>
+            <a:r>
+              <a:rPr lang="en-US" sz="1080" dirty="0">
+                <a:solidFill>
+                  <a:srgbClr val="ECECEC"/>
+                </a:solidFill>
+                <a:latin typeface="Courier New" pitchFamily="34" charset="0"/>
+                <a:cs typeface="Courier New" pitchFamily="34" charset="-120"/>
+              </a:rPr>
+              <a:t> </a:t>
+            </a:r>
+            <a:r>
+              <a:rPr lang="en-US" sz="1080" dirty="0">
+                <a:solidFill>
+                  <a:srgbClr val="ECECEC"/>
+                </a:solidFill>
+                <a:latin typeface="Courier New" pitchFamily="34" charset="0"/>
+                <a:ea typeface="Courier New" pitchFamily="34" charset="-122"/>
+                <a:cs typeface="Courier New" pitchFamily="34" charset="-120"/>
+              </a:rPr>
+              <a:t>— print DC</a:t>
+            </a:r>
+            <a:endParaRPr lang="en-US" sz="1080" dirty="0">
+              <a:solidFill>
+                <a:srgbClr val="ECECEC"/>
+              </a:solidFill>
+              <a:latin typeface="Courier New" pitchFamily="34" charset="0"/>
+              <a:cs typeface="Courier New" pitchFamily="34" charset="-120"/>
+            </a:endParaRPr>
           </a:p>
         </p:txBody>
       </p:sp>

</xml_diff>

<commit_message>
docs(training): store pdfs of the ppt presentations
</commit_message>
<xml_diff>
--- a/docs/presentations/introduction-to-edumatcher.pptx
+++ b/docs/presentations/introduction-to-edumatcher.pptx
@@ -237,7 +237,7 @@
           <a:p>
             <a:fld id="{5282F153-3F37-0F45-9E97-73ACFA13230C}" type="datetimeFigureOut">
               <a:rPr lang="en-US"/>
-              <a:t>8/5/26</a:t>
+              <a:t>8/7/26</a:t>
             </a:fld>
             <a:endParaRPr lang="en-US"/>
           </a:p>
@@ -3468,7 +3468,10 @@
           <a:bodyPr/>
           <a:lstStyle/>
           <a:p>
-            <a:endParaRPr lang="en-SE" dirty="0"/>
+            <a:r>
+              <a:rPr lang="en-SE" dirty="0"/>
+              <a:t>J</a:t>
+            </a:r>
           </a:p>
         </p:txBody>
       </p:sp>
@@ -3632,6 +3635,48 @@
               <a:t>A fully functional exchange matching engine — built for learning, research, and demonstration. Real order-book mechanics, auctions, risk controls, and a ZeroMQ message bus.</a:t>
             </a:r>
             <a:endParaRPr lang="en-US" sz="1250" dirty="0"/>
+          </a:p>
+        </p:txBody>
+      </p:sp>
+      <p:sp>
+        <p:nvSpPr>
+          <p:cNvPr id="8" name="TextBox 7">
+            <a:extLst>
+              <a:ext uri="{FF2B5EF4-FFF2-40B4-BE49-F238E27FC236}">
+                <a16:creationId xmlns:a16="http://schemas.microsoft.com/office/drawing/2014/main" id="{32C33A31-178C-01A0-34CC-415C91FF617F}"/>
+              </a:ext>
+            </a:extLst>
+          </p:cNvPr>
+          <p:cNvSpPr txBox="1"/>
+          <p:nvPr/>
+        </p:nvSpPr>
+        <p:spPr>
+          <a:xfrm>
+            <a:off x="7342701" y="4752898"/>
+            <a:ext cx="1718797" cy="307777"/>
+          </a:xfrm>
+          <a:prstGeom prst="rect">
+            <a:avLst/>
+          </a:prstGeom>
+          <a:noFill/>
+        </p:spPr>
+        <p:txBody>
+          <a:bodyPr wrap="square" rtlCol="0">
+            <a:spAutoFit/>
+          </a:bodyPr>
+          <a:lstStyle/>
+          <a:p>
+            <a:pPr algn="r"/>
+            <a:r>
+              <a:rPr lang="en-SE" sz="1400" i="1" dirty="0">
+                <a:solidFill>
+                  <a:schemeClr val="bg1">
+                    <a:lumMod val="50000"/>
+                  </a:schemeClr>
+                </a:solidFill>
+              </a:rPr>
+              <a:t>J. Persson, 2026</a:t>
+            </a:r>
           </a:p>
         </p:txBody>
       </p:sp>

</xml_diff>